<commit_message>
Update figures, add new refinement spreadsheet
- tried the POH bend angle refinement, unstable results.
</commit_message>
<xml_diff>
--- a/manuscript_figures.pptx
+++ b/manuscript_figures.pptx
@@ -273,7 +273,7 @@
           <a:p>
             <a:fld id="{FF24CA68-1E24-4B4A-B799-9C3DECDBF403}" type="datetimeFigureOut">
               <a:rPr lang="en-US" smtClean="0"/>
-              <a:t>5/29/2026</a:t>
+              <a:t>6/3/2026</a:t>
             </a:fld>
             <a:endParaRPr lang="en-US"/>
           </a:p>
@@ -471,7 +471,7 @@
           <a:p>
             <a:fld id="{FF24CA68-1E24-4B4A-B799-9C3DECDBF403}" type="datetimeFigureOut">
               <a:rPr lang="en-US" smtClean="0"/>
-              <a:t>5/29/2026</a:t>
+              <a:t>6/3/2026</a:t>
             </a:fld>
             <a:endParaRPr lang="en-US"/>
           </a:p>
@@ -679,7 +679,7 @@
           <a:p>
             <a:fld id="{FF24CA68-1E24-4B4A-B799-9C3DECDBF403}" type="datetimeFigureOut">
               <a:rPr lang="en-US" smtClean="0"/>
-              <a:t>5/29/2026</a:t>
+              <a:t>6/3/2026</a:t>
             </a:fld>
             <a:endParaRPr lang="en-US"/>
           </a:p>
@@ -877,7 +877,7 @@
           <a:p>
             <a:fld id="{FF24CA68-1E24-4B4A-B799-9C3DECDBF403}" type="datetimeFigureOut">
               <a:rPr lang="en-US" smtClean="0"/>
-              <a:t>5/29/2026</a:t>
+              <a:t>6/3/2026</a:t>
             </a:fld>
             <a:endParaRPr lang="en-US"/>
           </a:p>
@@ -1152,7 +1152,7 @@
           <a:p>
             <a:fld id="{FF24CA68-1E24-4B4A-B799-9C3DECDBF403}" type="datetimeFigureOut">
               <a:rPr lang="en-US" smtClean="0"/>
-              <a:t>5/29/2026</a:t>
+              <a:t>6/3/2026</a:t>
             </a:fld>
             <a:endParaRPr lang="en-US"/>
           </a:p>
@@ -1417,7 +1417,7 @@
           <a:p>
             <a:fld id="{FF24CA68-1E24-4B4A-B799-9C3DECDBF403}" type="datetimeFigureOut">
               <a:rPr lang="en-US" smtClean="0"/>
-              <a:t>5/29/2026</a:t>
+              <a:t>6/3/2026</a:t>
             </a:fld>
             <a:endParaRPr lang="en-US"/>
           </a:p>
@@ -1829,7 +1829,7 @@
           <a:p>
             <a:fld id="{FF24CA68-1E24-4B4A-B799-9C3DECDBF403}" type="datetimeFigureOut">
               <a:rPr lang="en-US" smtClean="0"/>
-              <a:t>5/29/2026</a:t>
+              <a:t>6/3/2026</a:t>
             </a:fld>
             <a:endParaRPr lang="en-US"/>
           </a:p>
@@ -1970,7 +1970,7 @@
           <a:p>
             <a:fld id="{FF24CA68-1E24-4B4A-B799-9C3DECDBF403}" type="datetimeFigureOut">
               <a:rPr lang="en-US" smtClean="0"/>
-              <a:t>5/29/2026</a:t>
+              <a:t>6/3/2026</a:t>
             </a:fld>
             <a:endParaRPr lang="en-US"/>
           </a:p>
@@ -2083,7 +2083,7 @@
           <a:p>
             <a:fld id="{FF24CA68-1E24-4B4A-B799-9C3DECDBF403}" type="datetimeFigureOut">
               <a:rPr lang="en-US" smtClean="0"/>
-              <a:t>5/29/2026</a:t>
+              <a:t>6/3/2026</a:t>
             </a:fld>
             <a:endParaRPr lang="en-US"/>
           </a:p>
@@ -2394,7 +2394,7 @@
           <a:p>
             <a:fld id="{FF24CA68-1E24-4B4A-B799-9C3DECDBF403}" type="datetimeFigureOut">
               <a:rPr lang="en-US" smtClean="0"/>
-              <a:t>5/29/2026</a:t>
+              <a:t>6/3/2026</a:t>
             </a:fld>
             <a:endParaRPr lang="en-US"/>
           </a:p>
@@ -2682,7 +2682,7 @@
           <a:p>
             <a:fld id="{FF24CA68-1E24-4B4A-B799-9C3DECDBF403}" type="datetimeFigureOut">
               <a:rPr lang="en-US" smtClean="0"/>
-              <a:t>5/29/2026</a:t>
+              <a:t>6/3/2026</a:t>
             </a:fld>
             <a:endParaRPr lang="en-US"/>
           </a:p>
@@ -2923,7 +2923,7 @@
           <a:p>
             <a:fld id="{FF24CA68-1E24-4B4A-B799-9C3DECDBF403}" type="datetimeFigureOut">
               <a:rPr lang="en-US" smtClean="0"/>
-              <a:t>5/29/2026</a:t>
+              <a:t>6/3/2026</a:t>
             </a:fld>
             <a:endParaRPr lang="en-US"/>
           </a:p>
@@ -17107,7 +17107,7 @@
               </p:nvSpPr>
               <p:spPr>
                 <a:xfrm>
-                  <a:off x="2165479" y="379351"/>
+                  <a:off x="2241328" y="592155"/>
                   <a:ext cx="593722" cy="1384995"/>
                 </a:xfrm>
                 <a:prstGeom prst="rect">
@@ -17193,7 +17193,7 @@
               </p:nvSpPr>
               <p:spPr>
                 <a:xfrm>
-                  <a:off x="2165479" y="379351"/>
+                  <a:off x="2241328" y="592155"/>
                   <a:ext cx="593722" cy="1384995"/>
                 </a:xfrm>
                 <a:prstGeom prst="rect">
@@ -17221,8 +17221,8 @@
             </p:sp>
           </mc:Fallback>
         </mc:AlternateContent>
-        <mc:AlternateContent xmlns:mc="http://schemas.openxmlformats.org/markup-compatibility/2006">
-          <mc:Choice xmlns:a14="http://schemas.microsoft.com/office/drawing/2010/main" Requires="a14">
+        <mc:AlternateContent xmlns:mc="http://schemas.openxmlformats.org/markup-compatibility/2006" xmlns:a14="http://schemas.microsoft.com/office/drawing/2010/main">
+          <mc:Choice Requires="a14">
             <p:sp>
               <p:nvSpPr>
                 <p:cNvPr id="7" name="TextBox 6">
@@ -17295,7 +17295,7 @@
               </p:txBody>
             </p:sp>
           </mc:Choice>
-          <mc:Fallback>
+          <mc:Fallback xmlns="">
             <p:sp>
               <p:nvSpPr>
                 <p:cNvPr id="7" name="TextBox 6">
@@ -18039,8 +18039,8 @@
             </a:p>
           </p:txBody>
         </p:sp>
-        <mc:AlternateContent xmlns:mc="http://schemas.openxmlformats.org/markup-compatibility/2006">
-          <mc:Choice xmlns:a14="http://schemas.microsoft.com/office/drawing/2010/main" Requires="a14">
+        <mc:AlternateContent xmlns:mc="http://schemas.openxmlformats.org/markup-compatibility/2006" xmlns:a14="http://schemas.microsoft.com/office/drawing/2010/main">
+          <mc:Choice Requires="a14">
             <p:sp>
               <p:nvSpPr>
                 <p:cNvPr id="28" name="TextBox 27">
@@ -18102,7 +18102,7 @@
               </p:txBody>
             </p:sp>
           </mc:Choice>
-          <mc:Fallback>
+          <mc:Fallback xmlns="">
             <p:sp>
               <p:nvSpPr>
                 <p:cNvPr id="28" name="TextBox 27">
@@ -18147,8 +18147,8 @@
             </p:sp>
           </mc:Fallback>
         </mc:AlternateContent>
-        <mc:AlternateContent xmlns:mc="http://schemas.openxmlformats.org/markup-compatibility/2006">
-          <mc:Choice xmlns:a14="http://schemas.microsoft.com/office/drawing/2010/main" Requires="a14">
+        <mc:AlternateContent xmlns:mc="http://schemas.openxmlformats.org/markup-compatibility/2006" xmlns:a14="http://schemas.microsoft.com/office/drawing/2010/main">
+          <mc:Choice Requires="a14">
             <p:sp>
               <p:nvSpPr>
                 <p:cNvPr id="29" name="TextBox 28">
@@ -18210,7 +18210,7 @@
               </p:txBody>
             </p:sp>
           </mc:Choice>
-          <mc:Fallback>
+          <mc:Fallback xmlns="">
             <p:sp>
               <p:nvSpPr>
                 <p:cNvPr id="29" name="TextBox 28">
@@ -18255,8 +18255,8 @@
             </p:sp>
           </mc:Fallback>
         </mc:AlternateContent>
-        <mc:AlternateContent xmlns:mc="http://schemas.openxmlformats.org/markup-compatibility/2006">
-          <mc:Choice xmlns:a14="http://schemas.microsoft.com/office/drawing/2010/main" Requires="a14">
+        <mc:AlternateContent xmlns:mc="http://schemas.openxmlformats.org/markup-compatibility/2006" xmlns:a14="http://schemas.microsoft.com/office/drawing/2010/main">
+          <mc:Choice Requires="a14">
             <p:sp>
               <p:nvSpPr>
                 <p:cNvPr id="30" name="TextBox 29">
@@ -18318,7 +18318,7 @@
               </p:txBody>
             </p:sp>
           </mc:Choice>
-          <mc:Fallback>
+          <mc:Fallback xmlns="">
             <p:sp>
               <p:nvSpPr>
                 <p:cNvPr id="30" name="TextBox 29">
@@ -18468,8 +18468,8 @@
             </a:p>
           </p:txBody>
         </p:sp>
-        <mc:AlternateContent xmlns:mc="http://schemas.openxmlformats.org/markup-compatibility/2006">
-          <mc:Choice xmlns:a14="http://schemas.microsoft.com/office/drawing/2010/main" Requires="a14">
+        <mc:AlternateContent xmlns:mc="http://schemas.openxmlformats.org/markup-compatibility/2006" xmlns:a14="http://schemas.microsoft.com/office/drawing/2010/main">
+          <mc:Choice Requires="a14">
             <p:sp>
               <p:nvSpPr>
                 <p:cNvPr id="34" name="TextBox 33">
@@ -18542,7 +18542,7 @@
               </p:txBody>
             </p:sp>
           </mc:Choice>
-          <mc:Fallback>
+          <mc:Fallback xmlns="">
             <p:sp>
               <p:nvSpPr>
                 <p:cNvPr id="34" name="TextBox 33">
@@ -18587,8 +18587,8 @@
             </p:sp>
           </mc:Fallback>
         </mc:AlternateContent>
-        <mc:AlternateContent xmlns:mc="http://schemas.openxmlformats.org/markup-compatibility/2006">
-          <mc:Choice xmlns:a14="http://schemas.microsoft.com/office/drawing/2010/main" Requires="a14">
+        <mc:AlternateContent xmlns:mc="http://schemas.openxmlformats.org/markup-compatibility/2006" xmlns:a14="http://schemas.microsoft.com/office/drawing/2010/main">
+          <mc:Choice Requires="a14">
             <p:sp>
               <p:nvSpPr>
                 <p:cNvPr id="35" name="TextBox 34">
@@ -18675,7 +18675,7 @@
               </p:txBody>
             </p:sp>
           </mc:Choice>
-          <mc:Fallback>
+          <mc:Fallback xmlns="">
             <p:sp>
               <p:nvSpPr>
                 <p:cNvPr id="35" name="TextBox 34">
@@ -18919,8 +18919,8 @@
             </a:prstGeom>
           </p:spPr>
         </p:pic>
-        <mc:AlternateContent xmlns:mc="http://schemas.openxmlformats.org/markup-compatibility/2006">
-          <mc:Choice xmlns:a14="http://schemas.microsoft.com/office/drawing/2010/main" Requires="a14">
+        <mc:AlternateContent xmlns:mc="http://schemas.openxmlformats.org/markup-compatibility/2006" xmlns:a14="http://schemas.microsoft.com/office/drawing/2010/main">
+          <mc:Choice Requires="a14">
             <p:sp>
               <p:nvSpPr>
                 <p:cNvPr id="4" name="Rectangle 3">
@@ -18996,7 +18996,7 @@
               </p:txBody>
             </p:sp>
           </mc:Choice>
-          <mc:Fallback>
+          <mc:Fallback xmlns="">
             <p:sp>
               <p:nvSpPr>
                 <p:cNvPr id="4" name="Rectangle 3">
@@ -19044,8 +19044,8 @@
             </p:sp>
           </mc:Fallback>
         </mc:AlternateContent>
-        <mc:AlternateContent xmlns:mc="http://schemas.openxmlformats.org/markup-compatibility/2006">
-          <mc:Choice xmlns:a14="http://schemas.microsoft.com/office/drawing/2010/main" Requires="a14">
+        <mc:AlternateContent xmlns:mc="http://schemas.openxmlformats.org/markup-compatibility/2006" xmlns:a14="http://schemas.microsoft.com/office/drawing/2010/main">
+          <mc:Choice Requires="a14">
             <p:sp>
               <p:nvSpPr>
                 <p:cNvPr id="8" name="Rectangle 7">
@@ -19121,7 +19121,7 @@
               </p:txBody>
             </p:sp>
           </mc:Choice>
-          <mc:Fallback>
+          <mc:Fallback xmlns="">
             <p:sp>
               <p:nvSpPr>
                 <p:cNvPr id="8" name="Rectangle 7">
@@ -19169,8 +19169,8 @@
             </p:sp>
           </mc:Fallback>
         </mc:AlternateContent>
-        <mc:AlternateContent xmlns:mc="http://schemas.openxmlformats.org/markup-compatibility/2006">
-          <mc:Choice xmlns:a14="http://schemas.microsoft.com/office/drawing/2010/main" Requires="a14">
+        <mc:AlternateContent xmlns:mc="http://schemas.openxmlformats.org/markup-compatibility/2006" xmlns:a14="http://schemas.microsoft.com/office/drawing/2010/main">
+          <mc:Choice Requires="a14">
             <p:sp>
               <p:nvSpPr>
                 <p:cNvPr id="9" name="Rectangle 8">
@@ -19246,7 +19246,7 @@
               </p:txBody>
             </p:sp>
           </mc:Choice>
-          <mc:Fallback>
+          <mc:Fallback xmlns="">
             <p:sp>
               <p:nvSpPr>
                 <p:cNvPr id="9" name="Rectangle 8">
@@ -19385,8 +19385,8 @@
             </a:fontRef>
           </p:style>
         </p:cxnSp>
-        <mc:AlternateContent xmlns:mc="http://schemas.openxmlformats.org/markup-compatibility/2006">
-          <mc:Choice xmlns:a14="http://schemas.microsoft.com/office/drawing/2010/main" Requires="a14">
+        <mc:AlternateContent xmlns:mc="http://schemas.openxmlformats.org/markup-compatibility/2006" xmlns:a14="http://schemas.microsoft.com/office/drawing/2010/main">
+          <mc:Choice Requires="a14">
             <p:sp>
               <p:nvSpPr>
                 <p:cNvPr id="25" name="Rectangle 24">
@@ -19462,7 +19462,7 @@
               </p:txBody>
             </p:sp>
           </mc:Choice>
-          <mc:Fallback>
+          <mc:Fallback xmlns="">
             <p:sp>
               <p:nvSpPr>
                 <p:cNvPr id="25" name="Rectangle 24">
@@ -19531,8 +19531,8 @@
             <a:chExt cx="4585545" cy="5586218"/>
           </a:xfrm>
         </p:grpSpPr>
-        <mc:AlternateContent xmlns:mc="http://schemas.openxmlformats.org/markup-compatibility/2006">
-          <mc:Choice xmlns:a14="http://schemas.microsoft.com/office/drawing/2010/main" Requires="a14">
+        <mc:AlternateContent xmlns:mc="http://schemas.openxmlformats.org/markup-compatibility/2006" xmlns:a14="http://schemas.microsoft.com/office/drawing/2010/main">
+          <mc:Choice Requires="a14">
             <p:sp>
               <p:nvSpPr>
                 <p:cNvPr id="170" name="TextBox 169">
@@ -19616,7 +19616,7 @@
               </p:txBody>
             </p:sp>
           </mc:Choice>
-          <mc:Fallback>
+          <mc:Fallback xmlns="">
             <p:sp>
               <p:nvSpPr>
                 <p:cNvPr id="170" name="TextBox 169">
@@ -19661,8 +19661,8 @@
             </p:sp>
           </mc:Fallback>
         </mc:AlternateContent>
-        <mc:AlternateContent xmlns:mc="http://schemas.openxmlformats.org/markup-compatibility/2006">
-          <mc:Choice xmlns:a14="http://schemas.microsoft.com/office/drawing/2010/main" Requires="a14">
+        <mc:AlternateContent xmlns:mc="http://schemas.openxmlformats.org/markup-compatibility/2006" xmlns:a14="http://schemas.microsoft.com/office/drawing/2010/main">
+          <mc:Choice Requires="a14">
             <p:sp>
               <p:nvSpPr>
                 <p:cNvPr id="151" name="TextBox 150">
@@ -19735,7 +19735,7 @@
               </p:txBody>
             </p:sp>
           </mc:Choice>
-          <mc:Fallback>
+          <mc:Fallback xmlns="">
             <p:sp>
               <p:nvSpPr>
                 <p:cNvPr id="151" name="TextBox 150">
@@ -20479,8 +20479,8 @@
             </a:p>
           </p:txBody>
         </p:sp>
-        <mc:AlternateContent xmlns:mc="http://schemas.openxmlformats.org/markup-compatibility/2006">
-          <mc:Choice xmlns:a14="http://schemas.microsoft.com/office/drawing/2010/main" Requires="a14">
+        <mc:AlternateContent xmlns:mc="http://schemas.openxmlformats.org/markup-compatibility/2006" xmlns:a14="http://schemas.microsoft.com/office/drawing/2010/main">
+          <mc:Choice Requires="a14">
             <p:sp>
               <p:nvSpPr>
                 <p:cNvPr id="136" name="TextBox 135">
@@ -20542,7 +20542,7 @@
               </p:txBody>
             </p:sp>
           </mc:Choice>
-          <mc:Fallback>
+          <mc:Fallback xmlns="">
             <p:sp>
               <p:nvSpPr>
                 <p:cNvPr id="136" name="TextBox 135">
@@ -20587,8 +20587,8 @@
             </p:sp>
           </mc:Fallback>
         </mc:AlternateContent>
-        <mc:AlternateContent xmlns:mc="http://schemas.openxmlformats.org/markup-compatibility/2006">
-          <mc:Choice xmlns:a14="http://schemas.microsoft.com/office/drawing/2010/main" Requires="a14">
+        <mc:AlternateContent xmlns:mc="http://schemas.openxmlformats.org/markup-compatibility/2006" xmlns:a14="http://schemas.microsoft.com/office/drawing/2010/main">
+          <mc:Choice Requires="a14">
             <p:sp>
               <p:nvSpPr>
                 <p:cNvPr id="137" name="TextBox 136">
@@ -20650,7 +20650,7 @@
               </p:txBody>
             </p:sp>
           </mc:Choice>
-          <mc:Fallback>
+          <mc:Fallback xmlns="">
             <p:sp>
               <p:nvSpPr>
                 <p:cNvPr id="137" name="TextBox 136">
@@ -20695,8 +20695,8 @@
             </p:sp>
           </mc:Fallback>
         </mc:AlternateContent>
-        <mc:AlternateContent xmlns:mc="http://schemas.openxmlformats.org/markup-compatibility/2006">
-          <mc:Choice xmlns:a14="http://schemas.microsoft.com/office/drawing/2010/main" Requires="a14">
+        <mc:AlternateContent xmlns:mc="http://schemas.openxmlformats.org/markup-compatibility/2006" xmlns:a14="http://schemas.microsoft.com/office/drawing/2010/main">
+          <mc:Choice Requires="a14">
             <p:sp>
               <p:nvSpPr>
                 <p:cNvPr id="138" name="TextBox 137">
@@ -20758,7 +20758,7 @@
               </p:txBody>
             </p:sp>
           </mc:Choice>
-          <mc:Fallback>
+          <mc:Fallback xmlns="">
             <p:sp>
               <p:nvSpPr>
                 <p:cNvPr id="138" name="TextBox 137">
@@ -20908,8 +20908,8 @@
             </a:p>
           </p:txBody>
         </p:sp>
-        <mc:AlternateContent xmlns:mc="http://schemas.openxmlformats.org/markup-compatibility/2006">
-          <mc:Choice xmlns:a14="http://schemas.microsoft.com/office/drawing/2010/main" Requires="a14">
+        <mc:AlternateContent xmlns:mc="http://schemas.openxmlformats.org/markup-compatibility/2006" xmlns:a14="http://schemas.microsoft.com/office/drawing/2010/main">
+          <mc:Choice Requires="a14">
             <p:sp>
               <p:nvSpPr>
                 <p:cNvPr id="160" name="TextBox 159">
@@ -20982,7 +20982,7 @@
               </p:txBody>
             </p:sp>
           </mc:Choice>
-          <mc:Fallback>
+          <mc:Fallback xmlns="">
             <p:sp>
               <p:nvSpPr>
                 <p:cNvPr id="160" name="TextBox 159">
@@ -21027,8 +21027,8 @@
             </p:sp>
           </mc:Fallback>
         </mc:AlternateContent>
-        <mc:AlternateContent xmlns:mc="http://schemas.openxmlformats.org/markup-compatibility/2006">
-          <mc:Choice xmlns:a14="http://schemas.microsoft.com/office/drawing/2010/main" Requires="a14">
+        <mc:AlternateContent xmlns:mc="http://schemas.openxmlformats.org/markup-compatibility/2006" xmlns:a14="http://schemas.microsoft.com/office/drawing/2010/main">
+          <mc:Choice Requires="a14">
             <p:sp>
               <p:nvSpPr>
                 <p:cNvPr id="163" name="TextBox 162">
@@ -21115,7 +21115,7 @@
               </p:txBody>
             </p:sp>
           </mc:Choice>
-          <mc:Fallback>
+          <mc:Fallback xmlns="">
             <p:sp>
               <p:nvSpPr>
                 <p:cNvPr id="163" name="TextBox 162">

</xml_diff>

<commit_message>
Produced HOPO abstract figure for conference
</commit_message>
<xml_diff>
--- a/manuscript_figures.pptx
+++ b/manuscript_figures.pptx
@@ -23,6 +23,7 @@
     <p:sldId id="264" r:id="rId17"/>
     <p:sldId id="265" r:id="rId18"/>
     <p:sldId id="267" r:id="rId19"/>
+    <p:sldId id="275" r:id="rId20"/>
   </p:sldIdLst>
   <p:sldSz cx="12192000" cy="6858000"/>
   <p:notesSz cx="6858000" cy="9144000"/>
@@ -927,7 +928,7 @@
           <a:p>
             <a:fld id="{FF24CA68-1E24-4B4A-B799-9C3DECDBF403}" type="datetimeFigureOut">
               <a:rPr lang="en-US" smtClean="0"/>
-              <a:t>7/8/2026</a:t>
+              <a:t>7/21/2026</a:t>
             </a:fld>
             <a:endParaRPr lang="en-US"/>
           </a:p>
@@ -1125,7 +1126,7 @@
           <a:p>
             <a:fld id="{FF24CA68-1E24-4B4A-B799-9C3DECDBF403}" type="datetimeFigureOut">
               <a:rPr lang="en-US" smtClean="0"/>
-              <a:t>7/8/2026</a:t>
+              <a:t>7/21/2026</a:t>
             </a:fld>
             <a:endParaRPr lang="en-US"/>
           </a:p>
@@ -1333,7 +1334,7 @@
           <a:p>
             <a:fld id="{FF24CA68-1E24-4B4A-B799-9C3DECDBF403}" type="datetimeFigureOut">
               <a:rPr lang="en-US" smtClean="0"/>
-              <a:t>7/8/2026</a:t>
+              <a:t>7/21/2026</a:t>
             </a:fld>
             <a:endParaRPr lang="en-US"/>
           </a:p>
@@ -1531,7 +1532,7 @@
           <a:p>
             <a:fld id="{FF24CA68-1E24-4B4A-B799-9C3DECDBF403}" type="datetimeFigureOut">
               <a:rPr lang="en-US" smtClean="0"/>
-              <a:t>7/8/2026</a:t>
+              <a:t>7/21/2026</a:t>
             </a:fld>
             <a:endParaRPr lang="en-US"/>
           </a:p>
@@ -1806,7 +1807,7 @@
           <a:p>
             <a:fld id="{FF24CA68-1E24-4B4A-B799-9C3DECDBF403}" type="datetimeFigureOut">
               <a:rPr lang="en-US" smtClean="0"/>
-              <a:t>7/8/2026</a:t>
+              <a:t>7/21/2026</a:t>
             </a:fld>
             <a:endParaRPr lang="en-US"/>
           </a:p>
@@ -2071,7 +2072,7 @@
           <a:p>
             <a:fld id="{FF24CA68-1E24-4B4A-B799-9C3DECDBF403}" type="datetimeFigureOut">
               <a:rPr lang="en-US" smtClean="0"/>
-              <a:t>7/8/2026</a:t>
+              <a:t>7/21/2026</a:t>
             </a:fld>
             <a:endParaRPr lang="en-US"/>
           </a:p>
@@ -2483,7 +2484,7 @@
           <a:p>
             <a:fld id="{FF24CA68-1E24-4B4A-B799-9C3DECDBF403}" type="datetimeFigureOut">
               <a:rPr lang="en-US" smtClean="0"/>
-              <a:t>7/8/2026</a:t>
+              <a:t>7/21/2026</a:t>
             </a:fld>
             <a:endParaRPr lang="en-US"/>
           </a:p>
@@ -2624,7 +2625,7 @@
           <a:p>
             <a:fld id="{FF24CA68-1E24-4B4A-B799-9C3DECDBF403}" type="datetimeFigureOut">
               <a:rPr lang="en-US" smtClean="0"/>
-              <a:t>7/8/2026</a:t>
+              <a:t>7/21/2026</a:t>
             </a:fld>
             <a:endParaRPr lang="en-US"/>
           </a:p>
@@ -2737,7 +2738,7 @@
           <a:p>
             <a:fld id="{FF24CA68-1E24-4B4A-B799-9C3DECDBF403}" type="datetimeFigureOut">
               <a:rPr lang="en-US" smtClean="0"/>
-              <a:t>7/8/2026</a:t>
+              <a:t>7/21/2026</a:t>
             </a:fld>
             <a:endParaRPr lang="en-US"/>
           </a:p>
@@ -3048,7 +3049,7 @@
           <a:p>
             <a:fld id="{FF24CA68-1E24-4B4A-B799-9C3DECDBF403}" type="datetimeFigureOut">
               <a:rPr lang="en-US" smtClean="0"/>
-              <a:t>7/8/2026</a:t>
+              <a:t>7/21/2026</a:t>
             </a:fld>
             <a:endParaRPr lang="en-US"/>
           </a:p>
@@ -3336,7 +3337,7 @@
           <a:p>
             <a:fld id="{FF24CA68-1E24-4B4A-B799-9C3DECDBF403}" type="datetimeFigureOut">
               <a:rPr lang="en-US" smtClean="0"/>
-              <a:t>7/8/2026</a:t>
+              <a:t>7/21/2026</a:t>
             </a:fld>
             <a:endParaRPr lang="en-US"/>
           </a:p>
@@ -3577,7 +3578,7 @@
           <a:p>
             <a:fld id="{FF24CA68-1E24-4B4A-B799-9C3DECDBF403}" type="datetimeFigureOut">
               <a:rPr lang="en-US" smtClean="0"/>
-              <a:t>7/8/2026</a:t>
+              <a:t>7/21/2026</a:t>
             </a:fld>
             <a:endParaRPr lang="en-US"/>
           </a:p>
@@ -11410,6 +11411,162 @@
 </p:sld>
 </file>
 
+<file path=ppt/slides/slide19.xml><?xml version="1.0" encoding="utf-8"?>
+<p:sld xmlns:a="http://schemas.openxmlformats.org/drawingml/2006/main" xmlns:r="http://schemas.openxmlformats.org/officeDocument/2006/relationships" xmlns:p="http://schemas.openxmlformats.org/presentationml/2006/main">
+  <p:cSld>
+    <p:spTree>
+      <p:nvGrpSpPr>
+        <p:cNvPr id="1" name=""/>
+        <p:cNvGrpSpPr/>
+        <p:nvPr/>
+      </p:nvGrpSpPr>
+      <p:grpSpPr>
+        <a:xfrm>
+          <a:off x="0" y="0"/>
+          <a:ext cx="0" cy="0"/>
+          <a:chOff x="0" y="0"/>
+          <a:chExt cx="0" cy="0"/>
+        </a:xfrm>
+      </p:grpSpPr>
+      <p:pic>
+        <p:nvPicPr>
+          <p:cNvPr id="26" name="Picture 25">
+            <a:extLst>
+              <a:ext uri="{FF2B5EF4-FFF2-40B4-BE49-F238E27FC236}">
+                <a16:creationId xmlns:a16="http://schemas.microsoft.com/office/drawing/2014/main" id="{23EAB303-589A-1E24-D83D-FE07D5E80DF6}"/>
+              </a:ext>
+            </a:extLst>
+          </p:cNvPr>
+          <p:cNvPicPr>
+            <a:picLocks noChangeAspect="1"/>
+          </p:cNvPicPr>
+          <p:nvPr/>
+        </p:nvPicPr>
+        <p:blipFill>
+          <a:blip r:embed="rId2"/>
+          <a:stretch>
+            <a:fillRect/>
+          </a:stretch>
+        </p:blipFill>
+        <p:spPr>
+          <a:xfrm>
+            <a:off x="5166652" y="63062"/>
+            <a:ext cx="3607191" cy="3435029"/>
+          </a:xfrm>
+          <a:prstGeom prst="rect">
+            <a:avLst/>
+          </a:prstGeom>
+        </p:spPr>
+      </p:pic>
+      <p:pic>
+        <p:nvPicPr>
+          <p:cNvPr id="30" name="Picture 29">
+            <a:extLst>
+              <a:ext uri="{FF2B5EF4-FFF2-40B4-BE49-F238E27FC236}">
+                <a16:creationId xmlns:a16="http://schemas.microsoft.com/office/drawing/2014/main" id="{65A86096-2147-BA74-8BCC-9FB9EAAC0260}"/>
+              </a:ext>
+            </a:extLst>
+          </p:cNvPr>
+          <p:cNvPicPr>
+            <a:picLocks noChangeAspect="1"/>
+          </p:cNvPicPr>
+          <p:nvPr/>
+        </p:nvPicPr>
+        <p:blipFill>
+          <a:blip r:embed="rId3"/>
+          <a:stretch>
+            <a:fillRect/>
+          </a:stretch>
+        </p:blipFill>
+        <p:spPr>
+          <a:xfrm>
+            <a:off x="1970690" y="119430"/>
+            <a:ext cx="3177901" cy="3321942"/>
+          </a:xfrm>
+          <a:prstGeom prst="rect">
+            <a:avLst/>
+          </a:prstGeom>
+        </p:spPr>
+      </p:pic>
+      <p:pic>
+        <p:nvPicPr>
+          <p:cNvPr id="38" name="Picture 37">
+            <a:extLst>
+              <a:ext uri="{FF2B5EF4-FFF2-40B4-BE49-F238E27FC236}">
+                <a16:creationId xmlns:a16="http://schemas.microsoft.com/office/drawing/2014/main" id="{56221293-EE61-834F-26D2-E735FCB5FD1E}"/>
+              </a:ext>
+            </a:extLst>
+          </p:cNvPr>
+          <p:cNvPicPr>
+            <a:picLocks noChangeAspect="1"/>
+          </p:cNvPicPr>
+          <p:nvPr/>
+        </p:nvPicPr>
+        <p:blipFill>
+          <a:blip r:embed="rId4"/>
+          <a:stretch>
+            <a:fillRect/>
+          </a:stretch>
+        </p:blipFill>
+        <p:spPr>
+          <a:xfrm>
+            <a:off x="1529255" y="3498091"/>
+            <a:ext cx="4073087" cy="2801890"/>
+          </a:xfrm>
+          <a:prstGeom prst="rect">
+            <a:avLst/>
+          </a:prstGeom>
+        </p:spPr>
+      </p:pic>
+      <p:pic>
+        <p:nvPicPr>
+          <p:cNvPr id="42" name="Picture 41">
+            <a:extLst>
+              <a:ext uri="{FF2B5EF4-FFF2-40B4-BE49-F238E27FC236}">
+                <a16:creationId xmlns:a16="http://schemas.microsoft.com/office/drawing/2014/main" id="{30C04889-1B52-E850-E670-2A24717A94A0}"/>
+              </a:ext>
+            </a:extLst>
+          </p:cNvPr>
+          <p:cNvPicPr>
+            <a:picLocks noChangeAspect="1"/>
+          </p:cNvPicPr>
+          <p:nvPr/>
+        </p:nvPicPr>
+        <p:blipFill>
+          <a:blip r:embed="rId5">
+            <a:extLst>
+              <a:ext uri="{28A0092B-C50C-407E-A947-70E740481C1C}">
+                <a14:useLocalDpi xmlns:a14="http://schemas.microsoft.com/office/drawing/2010/main" val="0"/>
+              </a:ext>
+            </a:extLst>
+          </a:blip>
+          <a:stretch>
+            <a:fillRect/>
+          </a:stretch>
+        </p:blipFill>
+        <p:spPr>
+          <a:xfrm>
+            <a:off x="5746530" y="3498091"/>
+            <a:ext cx="2971801" cy="2971801"/>
+          </a:xfrm>
+          <a:prstGeom prst="rect">
+            <a:avLst/>
+          </a:prstGeom>
+        </p:spPr>
+      </p:pic>
+    </p:spTree>
+    <p:extLst>
+      <p:ext uri="{BB962C8B-B14F-4D97-AF65-F5344CB8AC3E}">
+        <p14:creationId xmlns:p14="http://schemas.microsoft.com/office/powerpoint/2010/main" val="3858368022"/>
+      </p:ext>
+    </p:extLst>
+  </p:cSld>
+  <p:clrMapOvr>
+    <a:masterClrMapping/>
+  </p:clrMapOvr>
+</p:sld>
+</file>
+
 <file path=ppt/slides/slide2.xml><?xml version="1.0" encoding="utf-8"?>
 <p:sld xmlns:a="http://schemas.openxmlformats.org/drawingml/2006/main" xmlns:r="http://schemas.openxmlformats.org/officeDocument/2006/relationships" xmlns:p="http://schemas.openxmlformats.org/presentationml/2006/main">
   <p:cSld>
@@ -22042,8 +22199,8 @@
             </a:fontRef>
           </p:style>
         </p:cxnSp>
-        <mc:AlternateContent xmlns:mc="http://schemas.openxmlformats.org/markup-compatibility/2006">
-          <mc:Choice xmlns:a14="http://schemas.microsoft.com/office/drawing/2010/main" Requires="a14">
+        <mc:AlternateContent xmlns:mc="http://schemas.openxmlformats.org/markup-compatibility/2006" xmlns:a14="http://schemas.microsoft.com/office/drawing/2010/main">
+          <mc:Choice Requires="a14">
             <p:sp>
               <p:nvSpPr>
                 <p:cNvPr id="67" name="Subtitle 2">
@@ -22289,7 +22446,7 @@
               </p:txBody>
             </p:sp>
           </mc:Choice>
-          <mc:Fallback>
+          <mc:Fallback xmlns="">
             <p:sp>
               <p:nvSpPr>
                 <p:cNvPr id="67" name="Subtitle 2">
@@ -22334,8 +22491,8 @@
             </p:sp>
           </mc:Fallback>
         </mc:AlternateContent>
-        <mc:AlternateContent xmlns:mc="http://schemas.openxmlformats.org/markup-compatibility/2006">
-          <mc:Choice xmlns:a14="http://schemas.microsoft.com/office/drawing/2010/main" Requires="a14">
+        <mc:AlternateContent xmlns:mc="http://schemas.openxmlformats.org/markup-compatibility/2006" xmlns:a14="http://schemas.microsoft.com/office/drawing/2010/main">
+          <mc:Choice Requires="a14">
             <p:sp>
               <p:nvSpPr>
                 <p:cNvPr id="68" name="Subtitle 2">
@@ -22581,7 +22738,7 @@
               </p:txBody>
             </p:sp>
           </mc:Choice>
-          <mc:Fallback>
+          <mc:Fallback xmlns="">
             <p:sp>
               <p:nvSpPr>
                 <p:cNvPr id="68" name="Subtitle 2">
@@ -22626,8 +22783,8 @@
             </p:sp>
           </mc:Fallback>
         </mc:AlternateContent>
-        <mc:AlternateContent xmlns:mc="http://schemas.openxmlformats.org/markup-compatibility/2006">
-          <mc:Choice xmlns:a14="http://schemas.microsoft.com/office/drawing/2010/main" Requires="a14">
+        <mc:AlternateContent xmlns:mc="http://schemas.openxmlformats.org/markup-compatibility/2006" xmlns:a14="http://schemas.microsoft.com/office/drawing/2010/main">
+          <mc:Choice Requires="a14">
             <p:sp>
               <p:nvSpPr>
                 <p:cNvPr id="69" name="Subtitle 2">
@@ -22873,7 +23030,7 @@
               </p:txBody>
             </p:sp>
           </mc:Choice>
-          <mc:Fallback>
+          <mc:Fallback xmlns="">
             <p:sp>
               <p:nvSpPr>
                 <p:cNvPr id="69" name="Subtitle 2">
@@ -22971,8 +23128,8 @@
             </a:p>
           </p:txBody>
         </p:sp>
-        <mc:AlternateContent xmlns:mc="http://schemas.openxmlformats.org/markup-compatibility/2006">
-          <mc:Choice xmlns:a14="http://schemas.microsoft.com/office/drawing/2010/main" Requires="a14">
+        <mc:AlternateContent xmlns:mc="http://schemas.openxmlformats.org/markup-compatibility/2006" xmlns:a14="http://schemas.microsoft.com/office/drawing/2010/main">
+          <mc:Choice Requires="a14">
             <p:sp>
               <p:nvSpPr>
                 <p:cNvPr id="71" name="Subtitle 2">
@@ -23218,7 +23375,7 @@
               </p:txBody>
             </p:sp>
           </mc:Choice>
-          <mc:Fallback>
+          <mc:Fallback xmlns="">
             <p:sp>
               <p:nvSpPr>
                 <p:cNvPr id="71" name="Subtitle 2">
@@ -23316,8 +23473,8 @@
             </a:p>
           </p:txBody>
         </p:sp>
-        <mc:AlternateContent xmlns:mc="http://schemas.openxmlformats.org/markup-compatibility/2006">
-          <mc:Choice xmlns:a14="http://schemas.microsoft.com/office/drawing/2010/main" Requires="a14">
+        <mc:AlternateContent xmlns:mc="http://schemas.openxmlformats.org/markup-compatibility/2006" xmlns:a14="http://schemas.microsoft.com/office/drawing/2010/main">
+          <mc:Choice Requires="a14">
             <p:sp>
               <p:nvSpPr>
                 <p:cNvPr id="73" name="Subtitle 2">
@@ -23563,7 +23720,7 @@
               </p:txBody>
             </p:sp>
           </mc:Choice>
-          <mc:Fallback>
+          <mc:Fallback xmlns="">
             <p:sp>
               <p:nvSpPr>
                 <p:cNvPr id="73" name="Subtitle 2">
@@ -23662,8 +23819,8 @@
             </a:p>
           </p:txBody>
         </p:sp>
-        <mc:AlternateContent xmlns:mc="http://schemas.openxmlformats.org/markup-compatibility/2006">
-          <mc:Choice xmlns:a14="http://schemas.microsoft.com/office/drawing/2010/main" Requires="a14">
+        <mc:AlternateContent xmlns:mc="http://schemas.openxmlformats.org/markup-compatibility/2006" xmlns:a14="http://schemas.microsoft.com/office/drawing/2010/main">
+          <mc:Choice Requires="a14">
             <p:sp>
               <p:nvSpPr>
                 <p:cNvPr id="76" name="Subtitle 2">
@@ -23886,7 +24043,7 @@
               </p:txBody>
             </p:sp>
           </mc:Choice>
-          <mc:Fallback>
+          <mc:Fallback xmlns="">
             <p:sp>
               <p:nvSpPr>
                 <p:cNvPr id="76" name="Subtitle 2">
@@ -24113,8 +24270,8 @@
             <a:chExt cx="4585545" cy="5586218"/>
           </a:xfrm>
         </p:grpSpPr>
-        <mc:AlternateContent xmlns:mc="http://schemas.openxmlformats.org/markup-compatibility/2006">
-          <mc:Choice xmlns:a14="http://schemas.microsoft.com/office/drawing/2010/main" Requires="a14">
+        <mc:AlternateContent xmlns:mc="http://schemas.openxmlformats.org/markup-compatibility/2006" xmlns:a14="http://schemas.microsoft.com/office/drawing/2010/main">
+          <mc:Choice Requires="a14">
             <p:sp>
               <p:nvSpPr>
                 <p:cNvPr id="5" name="TextBox 4">
@@ -24198,7 +24355,7 @@
               </p:txBody>
             </p:sp>
           </mc:Choice>
-          <mc:Fallback>
+          <mc:Fallback xmlns="">
             <p:sp>
               <p:nvSpPr>
                 <p:cNvPr id="5" name="TextBox 4">
@@ -24243,8 +24400,8 @@
             </p:sp>
           </mc:Fallback>
         </mc:AlternateContent>
-        <mc:AlternateContent xmlns:mc="http://schemas.openxmlformats.org/markup-compatibility/2006">
-          <mc:Choice xmlns:a14="http://schemas.microsoft.com/office/drawing/2010/main" Requires="a14">
+        <mc:AlternateContent xmlns:mc="http://schemas.openxmlformats.org/markup-compatibility/2006" xmlns:a14="http://schemas.microsoft.com/office/drawing/2010/main">
+          <mc:Choice Requires="a14">
             <p:sp>
               <p:nvSpPr>
                 <p:cNvPr id="7" name="TextBox 6">
@@ -24317,7 +24474,7 @@
               </p:txBody>
             </p:sp>
           </mc:Choice>
-          <mc:Fallback>
+          <mc:Fallback xmlns="">
             <p:sp>
               <p:nvSpPr>
                 <p:cNvPr id="7" name="TextBox 6">
@@ -25061,8 +25218,8 @@
             </a:p>
           </p:txBody>
         </p:sp>
-        <mc:AlternateContent xmlns:mc="http://schemas.openxmlformats.org/markup-compatibility/2006">
-          <mc:Choice xmlns:a14="http://schemas.microsoft.com/office/drawing/2010/main" Requires="a14">
+        <mc:AlternateContent xmlns:mc="http://schemas.openxmlformats.org/markup-compatibility/2006" xmlns:a14="http://schemas.microsoft.com/office/drawing/2010/main">
+          <mc:Choice Requires="a14">
             <p:sp>
               <p:nvSpPr>
                 <p:cNvPr id="28" name="TextBox 27">
@@ -25124,7 +25281,7 @@
               </p:txBody>
             </p:sp>
           </mc:Choice>
-          <mc:Fallback>
+          <mc:Fallback xmlns="">
             <p:sp>
               <p:nvSpPr>
                 <p:cNvPr id="28" name="TextBox 27">
@@ -25169,8 +25326,8 @@
             </p:sp>
           </mc:Fallback>
         </mc:AlternateContent>
-        <mc:AlternateContent xmlns:mc="http://schemas.openxmlformats.org/markup-compatibility/2006">
-          <mc:Choice xmlns:a14="http://schemas.microsoft.com/office/drawing/2010/main" Requires="a14">
+        <mc:AlternateContent xmlns:mc="http://schemas.openxmlformats.org/markup-compatibility/2006" xmlns:a14="http://schemas.microsoft.com/office/drawing/2010/main">
+          <mc:Choice Requires="a14">
             <p:sp>
               <p:nvSpPr>
                 <p:cNvPr id="29" name="TextBox 28">
@@ -25232,7 +25389,7 @@
               </p:txBody>
             </p:sp>
           </mc:Choice>
-          <mc:Fallback>
+          <mc:Fallback xmlns="">
             <p:sp>
               <p:nvSpPr>
                 <p:cNvPr id="29" name="TextBox 28">
@@ -25277,8 +25434,8 @@
             </p:sp>
           </mc:Fallback>
         </mc:AlternateContent>
-        <mc:AlternateContent xmlns:mc="http://schemas.openxmlformats.org/markup-compatibility/2006">
-          <mc:Choice xmlns:a14="http://schemas.microsoft.com/office/drawing/2010/main" Requires="a14">
+        <mc:AlternateContent xmlns:mc="http://schemas.openxmlformats.org/markup-compatibility/2006" xmlns:a14="http://schemas.microsoft.com/office/drawing/2010/main">
+          <mc:Choice Requires="a14">
             <p:sp>
               <p:nvSpPr>
                 <p:cNvPr id="30" name="TextBox 29">
@@ -25340,7 +25497,7 @@
               </p:txBody>
             </p:sp>
           </mc:Choice>
-          <mc:Fallback>
+          <mc:Fallback xmlns="">
             <p:sp>
               <p:nvSpPr>
                 <p:cNvPr id="30" name="TextBox 29">
@@ -25490,8 +25647,8 @@
             </a:p>
           </p:txBody>
         </p:sp>
-        <mc:AlternateContent xmlns:mc="http://schemas.openxmlformats.org/markup-compatibility/2006">
-          <mc:Choice xmlns:a14="http://schemas.microsoft.com/office/drawing/2010/main" Requires="a14">
+        <mc:AlternateContent xmlns:mc="http://schemas.openxmlformats.org/markup-compatibility/2006" xmlns:a14="http://schemas.microsoft.com/office/drawing/2010/main">
+          <mc:Choice Requires="a14">
             <p:sp>
               <p:nvSpPr>
                 <p:cNvPr id="34" name="TextBox 33">
@@ -25593,7 +25750,7 @@
               </p:txBody>
             </p:sp>
           </mc:Choice>
-          <mc:Fallback>
+          <mc:Fallback xmlns="">
             <p:sp>
               <p:nvSpPr>
                 <p:cNvPr id="34" name="TextBox 33">
@@ -25638,8 +25795,8 @@
             </p:sp>
           </mc:Fallback>
         </mc:AlternateContent>
-        <mc:AlternateContent xmlns:mc="http://schemas.openxmlformats.org/markup-compatibility/2006">
-          <mc:Choice xmlns:a14="http://schemas.microsoft.com/office/drawing/2010/main" Requires="a14">
+        <mc:AlternateContent xmlns:mc="http://schemas.openxmlformats.org/markup-compatibility/2006" xmlns:a14="http://schemas.microsoft.com/office/drawing/2010/main">
+          <mc:Choice Requires="a14">
             <p:sp>
               <p:nvSpPr>
                 <p:cNvPr id="35" name="TextBox 34">
@@ -25752,7 +25909,7 @@
               </p:txBody>
             </p:sp>
           </mc:Choice>
-          <mc:Fallback>
+          <mc:Fallback xmlns="">
             <p:sp>
               <p:nvSpPr>
                 <p:cNvPr id="35" name="TextBox 34">
@@ -26526,8 +26683,8 @@
             </a:fontRef>
           </p:style>
         </p:cxnSp>
-        <mc:AlternateContent xmlns:mc="http://schemas.openxmlformats.org/markup-compatibility/2006">
-          <mc:Choice xmlns:a14="http://schemas.microsoft.com/office/drawing/2010/main" Requires="a14">
+        <mc:AlternateContent xmlns:mc="http://schemas.openxmlformats.org/markup-compatibility/2006" xmlns:a14="http://schemas.microsoft.com/office/drawing/2010/main">
+          <mc:Choice Requires="a14">
             <p:sp>
               <p:nvSpPr>
                 <p:cNvPr id="67" name="Subtitle 2">
@@ -26773,7 +26930,7 @@
               </p:txBody>
             </p:sp>
           </mc:Choice>
-          <mc:Fallback>
+          <mc:Fallback xmlns="">
             <p:sp>
               <p:nvSpPr>
                 <p:cNvPr id="67" name="Subtitle 2">
@@ -26818,8 +26975,8 @@
             </p:sp>
           </mc:Fallback>
         </mc:AlternateContent>
-        <mc:AlternateContent xmlns:mc="http://schemas.openxmlformats.org/markup-compatibility/2006">
-          <mc:Choice xmlns:a14="http://schemas.microsoft.com/office/drawing/2010/main" Requires="a14">
+        <mc:AlternateContent xmlns:mc="http://schemas.openxmlformats.org/markup-compatibility/2006" xmlns:a14="http://schemas.microsoft.com/office/drawing/2010/main">
+          <mc:Choice Requires="a14">
             <p:sp>
               <p:nvSpPr>
                 <p:cNvPr id="68" name="Subtitle 2">
@@ -27065,7 +27222,7 @@
               </p:txBody>
             </p:sp>
           </mc:Choice>
-          <mc:Fallback>
+          <mc:Fallback xmlns="">
             <p:sp>
               <p:nvSpPr>
                 <p:cNvPr id="68" name="Subtitle 2">
@@ -27110,8 +27267,8 @@
             </p:sp>
           </mc:Fallback>
         </mc:AlternateContent>
-        <mc:AlternateContent xmlns:mc="http://schemas.openxmlformats.org/markup-compatibility/2006">
-          <mc:Choice xmlns:a14="http://schemas.microsoft.com/office/drawing/2010/main" Requires="a14">
+        <mc:AlternateContent xmlns:mc="http://schemas.openxmlformats.org/markup-compatibility/2006" xmlns:a14="http://schemas.microsoft.com/office/drawing/2010/main">
+          <mc:Choice Requires="a14">
             <p:sp>
               <p:nvSpPr>
                 <p:cNvPr id="69" name="Subtitle 2">
@@ -27357,7 +27514,7 @@
               </p:txBody>
             </p:sp>
           </mc:Choice>
-          <mc:Fallback>
+          <mc:Fallback xmlns="">
             <p:sp>
               <p:nvSpPr>
                 <p:cNvPr id="69" name="Subtitle 2">
@@ -27455,8 +27612,8 @@
             </a:p>
           </p:txBody>
         </p:sp>
-        <mc:AlternateContent xmlns:mc="http://schemas.openxmlformats.org/markup-compatibility/2006">
-          <mc:Choice xmlns:a14="http://schemas.microsoft.com/office/drawing/2010/main" Requires="a14">
+        <mc:AlternateContent xmlns:mc="http://schemas.openxmlformats.org/markup-compatibility/2006" xmlns:a14="http://schemas.microsoft.com/office/drawing/2010/main">
+          <mc:Choice Requires="a14">
             <p:sp>
               <p:nvSpPr>
                 <p:cNvPr id="71" name="Subtitle 2">
@@ -27702,7 +27859,7 @@
               </p:txBody>
             </p:sp>
           </mc:Choice>
-          <mc:Fallback>
+          <mc:Fallback xmlns="">
             <p:sp>
               <p:nvSpPr>
                 <p:cNvPr id="71" name="Subtitle 2">
@@ -27800,8 +27957,8 @@
             </a:p>
           </p:txBody>
         </p:sp>
-        <mc:AlternateContent xmlns:mc="http://schemas.openxmlformats.org/markup-compatibility/2006">
-          <mc:Choice xmlns:a14="http://schemas.microsoft.com/office/drawing/2010/main" Requires="a14">
+        <mc:AlternateContent xmlns:mc="http://schemas.openxmlformats.org/markup-compatibility/2006" xmlns:a14="http://schemas.microsoft.com/office/drawing/2010/main">
+          <mc:Choice Requires="a14">
             <p:sp>
               <p:nvSpPr>
                 <p:cNvPr id="73" name="Subtitle 2">
@@ -28047,7 +28204,7 @@
               </p:txBody>
             </p:sp>
           </mc:Choice>
-          <mc:Fallback>
+          <mc:Fallback xmlns="">
             <p:sp>
               <p:nvSpPr>
                 <p:cNvPr id="73" name="Subtitle 2">
@@ -28146,8 +28303,8 @@
             </a:p>
           </p:txBody>
         </p:sp>
-        <mc:AlternateContent xmlns:mc="http://schemas.openxmlformats.org/markup-compatibility/2006">
-          <mc:Choice xmlns:a14="http://schemas.microsoft.com/office/drawing/2010/main" Requires="a14">
+        <mc:AlternateContent xmlns:mc="http://schemas.openxmlformats.org/markup-compatibility/2006" xmlns:a14="http://schemas.microsoft.com/office/drawing/2010/main">
+          <mc:Choice Requires="a14">
             <p:sp>
               <p:nvSpPr>
                 <p:cNvPr id="76" name="Subtitle 2">
@@ -28370,7 +28527,7 @@
               </p:txBody>
             </p:sp>
           </mc:Choice>
-          <mc:Fallback>
+          <mc:Fallback xmlns="">
             <p:sp>
               <p:nvSpPr>
                 <p:cNvPr id="76" name="Subtitle 2">
@@ -28577,8 +28734,8 @@
           </p:txBody>
         </p:sp>
       </p:grpSp>
-      <mc:AlternateContent xmlns:mc="http://schemas.openxmlformats.org/markup-compatibility/2006">
-        <mc:Choice xmlns:a14="http://schemas.microsoft.com/office/drawing/2010/main" Requires="a14">
+      <mc:AlternateContent xmlns:mc="http://schemas.openxmlformats.org/markup-compatibility/2006" xmlns:a14="http://schemas.microsoft.com/office/drawing/2010/main">
+        <mc:Choice Requires="a14">
           <p:sp>
             <p:nvSpPr>
               <p:cNvPr id="5" name="TextBox 4">
@@ -28662,7 +28819,7 @@
             </p:txBody>
           </p:sp>
         </mc:Choice>
-        <mc:Fallback>
+        <mc:Fallback xmlns="">
           <p:sp>
             <p:nvSpPr>
               <p:cNvPr id="5" name="TextBox 4">
@@ -28707,8 +28864,8 @@
           </p:sp>
         </mc:Fallback>
       </mc:AlternateContent>
-      <mc:AlternateContent xmlns:mc="http://schemas.openxmlformats.org/markup-compatibility/2006">
-        <mc:Choice xmlns:a14="http://schemas.microsoft.com/office/drawing/2010/main" Requires="a14">
+      <mc:AlternateContent xmlns:mc="http://schemas.openxmlformats.org/markup-compatibility/2006" xmlns:a14="http://schemas.microsoft.com/office/drawing/2010/main">
+        <mc:Choice Requires="a14">
           <p:sp>
             <p:nvSpPr>
               <p:cNvPr id="7" name="TextBox 6">
@@ -28781,7 +28938,7 @@
             </p:txBody>
           </p:sp>
         </mc:Choice>
-        <mc:Fallback>
+        <mc:Fallback xmlns="">
           <p:sp>
             <p:nvSpPr>
               <p:cNvPr id="7" name="TextBox 6">
@@ -29524,8 +29681,8 @@
           </a:p>
         </p:txBody>
       </p:sp>
-      <mc:AlternateContent xmlns:mc="http://schemas.openxmlformats.org/markup-compatibility/2006">
-        <mc:Choice xmlns:a14="http://schemas.microsoft.com/office/drawing/2010/main" Requires="a14">
+      <mc:AlternateContent xmlns:mc="http://schemas.openxmlformats.org/markup-compatibility/2006" xmlns:a14="http://schemas.microsoft.com/office/drawing/2010/main">
+        <mc:Choice Requires="a14">
           <p:sp>
             <p:nvSpPr>
               <p:cNvPr id="28" name="TextBox 27">
@@ -29587,7 +29744,7 @@
             </p:txBody>
           </p:sp>
         </mc:Choice>
-        <mc:Fallback>
+        <mc:Fallback xmlns="">
           <p:sp>
             <p:nvSpPr>
               <p:cNvPr id="28" name="TextBox 27">
@@ -29632,8 +29789,8 @@
           </p:sp>
         </mc:Fallback>
       </mc:AlternateContent>
-      <mc:AlternateContent xmlns:mc="http://schemas.openxmlformats.org/markup-compatibility/2006">
-        <mc:Choice xmlns:a14="http://schemas.microsoft.com/office/drawing/2010/main" Requires="a14">
+      <mc:AlternateContent xmlns:mc="http://schemas.openxmlformats.org/markup-compatibility/2006" xmlns:a14="http://schemas.microsoft.com/office/drawing/2010/main">
+        <mc:Choice Requires="a14">
           <p:sp>
             <p:nvSpPr>
               <p:cNvPr id="29" name="TextBox 28">
@@ -29695,7 +29852,7 @@
             </p:txBody>
           </p:sp>
         </mc:Choice>
-        <mc:Fallback>
+        <mc:Fallback xmlns="">
           <p:sp>
             <p:nvSpPr>
               <p:cNvPr id="29" name="TextBox 28">
@@ -29740,8 +29897,8 @@
           </p:sp>
         </mc:Fallback>
       </mc:AlternateContent>
-      <mc:AlternateContent xmlns:mc="http://schemas.openxmlformats.org/markup-compatibility/2006">
-        <mc:Choice xmlns:a14="http://schemas.microsoft.com/office/drawing/2010/main" Requires="a14">
+      <mc:AlternateContent xmlns:mc="http://schemas.openxmlformats.org/markup-compatibility/2006" xmlns:a14="http://schemas.microsoft.com/office/drawing/2010/main">
+        <mc:Choice Requires="a14">
           <p:sp>
             <p:nvSpPr>
               <p:cNvPr id="30" name="TextBox 29">
@@ -29803,7 +29960,7 @@
             </p:txBody>
           </p:sp>
         </mc:Choice>
-        <mc:Fallback>
+        <mc:Fallback xmlns="">
           <p:sp>
             <p:nvSpPr>
               <p:cNvPr id="30" name="TextBox 29">
@@ -29902,8 +30059,8 @@
           </a:p>
         </p:txBody>
       </p:sp>
-      <mc:AlternateContent xmlns:mc="http://schemas.openxmlformats.org/markup-compatibility/2006">
-        <mc:Choice xmlns:a14="http://schemas.microsoft.com/office/drawing/2010/main" Requires="a14">
+      <mc:AlternateContent xmlns:mc="http://schemas.openxmlformats.org/markup-compatibility/2006" xmlns:a14="http://schemas.microsoft.com/office/drawing/2010/main">
+        <mc:Choice Requires="a14">
           <p:sp>
             <p:nvSpPr>
               <p:cNvPr id="34" name="TextBox 33">
@@ -30005,7 +30162,7 @@
             </p:txBody>
           </p:sp>
         </mc:Choice>
-        <mc:Fallback>
+        <mc:Fallback xmlns="">
           <p:sp>
             <p:nvSpPr>
               <p:cNvPr id="34" name="TextBox 33">
@@ -30050,8 +30207,8 @@
           </p:sp>
         </mc:Fallback>
       </mc:AlternateContent>
-      <mc:AlternateContent xmlns:mc="http://schemas.openxmlformats.org/markup-compatibility/2006">
-        <mc:Choice xmlns:a14="http://schemas.microsoft.com/office/drawing/2010/main" Requires="a14">
+      <mc:AlternateContent xmlns:mc="http://schemas.openxmlformats.org/markup-compatibility/2006" xmlns:a14="http://schemas.microsoft.com/office/drawing/2010/main">
+        <mc:Choice Requires="a14">
           <p:sp>
             <p:nvSpPr>
               <p:cNvPr id="35" name="TextBox 34">
@@ -30164,7 +30321,7 @@
             </p:txBody>
           </p:sp>
         </mc:Choice>
-        <mc:Fallback>
+        <mc:Fallback xmlns="">
           <p:sp>
             <p:nvSpPr>
               <p:cNvPr id="35" name="TextBox 34">
@@ -30991,8 +31148,8 @@
             </a:fontRef>
           </p:style>
         </p:cxnSp>
-        <mc:AlternateContent xmlns:mc="http://schemas.openxmlformats.org/markup-compatibility/2006">
-          <mc:Choice xmlns:a14="http://schemas.microsoft.com/office/drawing/2010/main" Requires="a14">
+        <mc:AlternateContent xmlns:mc="http://schemas.openxmlformats.org/markup-compatibility/2006" xmlns:a14="http://schemas.microsoft.com/office/drawing/2010/main">
+          <mc:Choice Requires="a14">
             <p:sp>
               <p:nvSpPr>
                 <p:cNvPr id="67" name="Subtitle 2">
@@ -31238,7 +31395,7 @@
               </p:txBody>
             </p:sp>
           </mc:Choice>
-          <mc:Fallback>
+          <mc:Fallback xmlns="">
             <p:sp>
               <p:nvSpPr>
                 <p:cNvPr id="67" name="Subtitle 2">
@@ -31283,8 +31440,8 @@
             </p:sp>
           </mc:Fallback>
         </mc:AlternateContent>
-        <mc:AlternateContent xmlns:mc="http://schemas.openxmlformats.org/markup-compatibility/2006">
-          <mc:Choice xmlns:a14="http://schemas.microsoft.com/office/drawing/2010/main" Requires="a14">
+        <mc:AlternateContent xmlns:mc="http://schemas.openxmlformats.org/markup-compatibility/2006" xmlns:a14="http://schemas.microsoft.com/office/drawing/2010/main">
+          <mc:Choice Requires="a14">
             <p:sp>
               <p:nvSpPr>
                 <p:cNvPr id="68" name="Subtitle 2">
@@ -31530,7 +31687,7 @@
               </p:txBody>
             </p:sp>
           </mc:Choice>
-          <mc:Fallback>
+          <mc:Fallback xmlns="">
             <p:sp>
               <p:nvSpPr>
                 <p:cNvPr id="68" name="Subtitle 2">
@@ -31575,8 +31732,8 @@
             </p:sp>
           </mc:Fallback>
         </mc:AlternateContent>
-        <mc:AlternateContent xmlns:mc="http://schemas.openxmlformats.org/markup-compatibility/2006">
-          <mc:Choice xmlns:a14="http://schemas.microsoft.com/office/drawing/2010/main" Requires="a14">
+        <mc:AlternateContent xmlns:mc="http://schemas.openxmlformats.org/markup-compatibility/2006" xmlns:a14="http://schemas.microsoft.com/office/drawing/2010/main">
+          <mc:Choice Requires="a14">
             <p:sp>
               <p:nvSpPr>
                 <p:cNvPr id="69" name="Subtitle 2">
@@ -31822,7 +31979,7 @@
               </p:txBody>
             </p:sp>
           </mc:Choice>
-          <mc:Fallback>
+          <mc:Fallback xmlns="">
             <p:sp>
               <p:nvSpPr>
                 <p:cNvPr id="69" name="Subtitle 2">
@@ -31920,8 +32077,8 @@
             </a:p>
           </p:txBody>
         </p:sp>
-        <mc:AlternateContent xmlns:mc="http://schemas.openxmlformats.org/markup-compatibility/2006">
-          <mc:Choice xmlns:a14="http://schemas.microsoft.com/office/drawing/2010/main" Requires="a14">
+        <mc:AlternateContent xmlns:mc="http://schemas.openxmlformats.org/markup-compatibility/2006" xmlns:a14="http://schemas.microsoft.com/office/drawing/2010/main">
+          <mc:Choice Requires="a14">
             <p:sp>
               <p:nvSpPr>
                 <p:cNvPr id="71" name="Subtitle 2">
@@ -32167,7 +32324,7 @@
               </p:txBody>
             </p:sp>
           </mc:Choice>
-          <mc:Fallback>
+          <mc:Fallback xmlns="">
             <p:sp>
               <p:nvSpPr>
                 <p:cNvPr id="71" name="Subtitle 2">
@@ -32265,8 +32422,8 @@
             </a:p>
           </p:txBody>
         </p:sp>
-        <mc:AlternateContent xmlns:mc="http://schemas.openxmlformats.org/markup-compatibility/2006">
-          <mc:Choice xmlns:a14="http://schemas.microsoft.com/office/drawing/2010/main" Requires="a14">
+        <mc:AlternateContent xmlns:mc="http://schemas.openxmlformats.org/markup-compatibility/2006" xmlns:a14="http://schemas.microsoft.com/office/drawing/2010/main">
+          <mc:Choice Requires="a14">
             <p:sp>
               <p:nvSpPr>
                 <p:cNvPr id="73" name="Subtitle 2">
@@ -32512,7 +32669,7 @@
               </p:txBody>
             </p:sp>
           </mc:Choice>
-          <mc:Fallback>
+          <mc:Fallback xmlns="">
             <p:sp>
               <p:nvSpPr>
                 <p:cNvPr id="73" name="Subtitle 2">
@@ -32611,8 +32768,8 @@
             </a:p>
           </p:txBody>
         </p:sp>
-        <mc:AlternateContent xmlns:mc="http://schemas.openxmlformats.org/markup-compatibility/2006">
-          <mc:Choice xmlns:a14="http://schemas.microsoft.com/office/drawing/2010/main" Requires="a14">
+        <mc:AlternateContent xmlns:mc="http://schemas.openxmlformats.org/markup-compatibility/2006" xmlns:a14="http://schemas.microsoft.com/office/drawing/2010/main">
+          <mc:Choice Requires="a14">
             <p:sp>
               <p:nvSpPr>
                 <p:cNvPr id="76" name="Subtitle 2">
@@ -32835,7 +32992,7 @@
               </p:txBody>
             </p:sp>
           </mc:Choice>
-          <mc:Fallback>
+          <mc:Fallback xmlns="">
             <p:sp>
               <p:nvSpPr>
                 <p:cNvPr id="76" name="Subtitle 2">
@@ -33116,8 +33273,8 @@
             </a:p>
           </p:txBody>
         </p:sp>
-        <mc:AlternateContent xmlns:mc="http://schemas.openxmlformats.org/markup-compatibility/2006">
-          <mc:Choice xmlns:a14="http://schemas.microsoft.com/office/drawing/2010/main" Requires="a14">
+        <mc:AlternateContent xmlns:mc="http://schemas.openxmlformats.org/markup-compatibility/2006" xmlns:a14="http://schemas.microsoft.com/office/drawing/2010/main">
+          <mc:Choice Requires="a14">
             <p:sp>
               <p:nvSpPr>
                 <p:cNvPr id="5" name="TextBox 4">
@@ -33201,7 +33358,7 @@
               </p:txBody>
             </p:sp>
           </mc:Choice>
-          <mc:Fallback>
+          <mc:Fallback xmlns="">
             <p:sp>
               <p:nvSpPr>
                 <p:cNvPr id="5" name="TextBox 4">
@@ -33246,8 +33403,8 @@
             </p:sp>
           </mc:Fallback>
         </mc:AlternateContent>
-        <mc:AlternateContent xmlns:mc="http://schemas.openxmlformats.org/markup-compatibility/2006">
-          <mc:Choice xmlns:a14="http://schemas.microsoft.com/office/drawing/2010/main" Requires="a14">
+        <mc:AlternateContent xmlns:mc="http://schemas.openxmlformats.org/markup-compatibility/2006" xmlns:a14="http://schemas.microsoft.com/office/drawing/2010/main">
+          <mc:Choice Requires="a14">
             <p:sp>
               <p:nvSpPr>
                 <p:cNvPr id="7" name="TextBox 6">
@@ -33320,7 +33477,7 @@
               </p:txBody>
             </p:sp>
           </mc:Choice>
-          <mc:Fallback>
+          <mc:Fallback xmlns="">
             <p:sp>
               <p:nvSpPr>
                 <p:cNvPr id="7" name="TextBox 6">
@@ -33814,8 +33971,8 @@
             </a:p>
           </p:txBody>
         </p:sp>
-        <mc:AlternateContent xmlns:mc="http://schemas.openxmlformats.org/markup-compatibility/2006">
-          <mc:Choice xmlns:a14="http://schemas.microsoft.com/office/drawing/2010/main" Requires="a14">
+        <mc:AlternateContent xmlns:mc="http://schemas.openxmlformats.org/markup-compatibility/2006" xmlns:a14="http://schemas.microsoft.com/office/drawing/2010/main">
+          <mc:Choice Requires="a14">
             <p:sp>
               <p:nvSpPr>
                 <p:cNvPr id="28" name="TextBox 27">
@@ -33877,7 +34034,7 @@
               </p:txBody>
             </p:sp>
           </mc:Choice>
-          <mc:Fallback>
+          <mc:Fallback xmlns="">
             <p:sp>
               <p:nvSpPr>
                 <p:cNvPr id="28" name="TextBox 27">
@@ -33922,8 +34079,8 @@
             </p:sp>
           </mc:Fallback>
         </mc:AlternateContent>
-        <mc:AlternateContent xmlns:mc="http://schemas.openxmlformats.org/markup-compatibility/2006">
-          <mc:Choice xmlns:a14="http://schemas.microsoft.com/office/drawing/2010/main" Requires="a14">
+        <mc:AlternateContent xmlns:mc="http://schemas.openxmlformats.org/markup-compatibility/2006" xmlns:a14="http://schemas.microsoft.com/office/drawing/2010/main">
+          <mc:Choice Requires="a14">
             <p:sp>
               <p:nvSpPr>
                 <p:cNvPr id="29" name="TextBox 28">
@@ -33985,7 +34142,7 @@
               </p:txBody>
             </p:sp>
           </mc:Choice>
-          <mc:Fallback>
+          <mc:Fallback xmlns="">
             <p:sp>
               <p:nvSpPr>
                 <p:cNvPr id="29" name="TextBox 28">
@@ -34030,8 +34187,8 @@
             </p:sp>
           </mc:Fallback>
         </mc:AlternateContent>
-        <mc:AlternateContent xmlns:mc="http://schemas.openxmlformats.org/markup-compatibility/2006">
-          <mc:Choice xmlns:a14="http://schemas.microsoft.com/office/drawing/2010/main" Requires="a14">
+        <mc:AlternateContent xmlns:mc="http://schemas.openxmlformats.org/markup-compatibility/2006" xmlns:a14="http://schemas.microsoft.com/office/drawing/2010/main">
+          <mc:Choice Requires="a14">
             <p:sp>
               <p:nvSpPr>
                 <p:cNvPr id="30" name="TextBox 29">
@@ -34093,7 +34250,7 @@
               </p:txBody>
             </p:sp>
           </mc:Choice>
-          <mc:Fallback>
+          <mc:Fallback xmlns="">
             <p:sp>
               <p:nvSpPr>
                 <p:cNvPr id="30" name="TextBox 29">
@@ -34138,8 +34295,8 @@
             </p:sp>
           </mc:Fallback>
         </mc:AlternateContent>
-        <mc:AlternateContent xmlns:mc="http://schemas.openxmlformats.org/markup-compatibility/2006">
-          <mc:Choice xmlns:a14="http://schemas.microsoft.com/office/drawing/2010/main" Requires="a14">
+        <mc:AlternateContent xmlns:mc="http://schemas.openxmlformats.org/markup-compatibility/2006" xmlns:a14="http://schemas.microsoft.com/office/drawing/2010/main">
+          <mc:Choice Requires="a14">
             <p:sp>
               <p:nvSpPr>
                 <p:cNvPr id="34" name="TextBox 33">
@@ -34241,7 +34398,7 @@
               </p:txBody>
             </p:sp>
           </mc:Choice>
-          <mc:Fallback>
+          <mc:Fallback xmlns="">
             <p:sp>
               <p:nvSpPr>
                 <p:cNvPr id="34" name="TextBox 33">
@@ -34286,8 +34443,8 @@
             </p:sp>
           </mc:Fallback>
         </mc:AlternateContent>
-        <mc:AlternateContent xmlns:mc="http://schemas.openxmlformats.org/markup-compatibility/2006">
-          <mc:Choice xmlns:a14="http://schemas.microsoft.com/office/drawing/2010/main" Requires="a14">
+        <mc:AlternateContent xmlns:mc="http://schemas.openxmlformats.org/markup-compatibility/2006" xmlns:a14="http://schemas.microsoft.com/office/drawing/2010/main">
+          <mc:Choice Requires="a14">
             <p:sp>
               <p:nvSpPr>
                 <p:cNvPr id="35" name="TextBox 34">
@@ -34400,7 +34557,7 @@
               </p:txBody>
             </p:sp>
           </mc:Choice>
-          <mc:Fallback>
+          <mc:Fallback xmlns="">
             <p:sp>
               <p:nvSpPr>
                 <p:cNvPr id="35" name="TextBox 34">

</xml_diff>